<commit_message>
Fixed text formating in slides
</commit_message>
<xml_diff>
--- a/templates/Brochure_template_leaflet_4sides/Brochure_template_leaflet_4sides_1.pptx
+++ b/templates/Brochure_template_leaflet_4sides/Brochure_template_leaflet_4sides_1.pptx
@@ -112,7 +112,7 @@
 <file path=ppt/revisionInfo.xml><?xml version="1.0" encoding="utf-8"?>
 <p1510:revInfo xmlns:a="http://schemas.openxmlformats.org/drawingml/2006/main" xmlns:r="http://schemas.openxmlformats.org/officeDocument/2006/relationships" xmlns:p1510="http://schemas.microsoft.com/office/powerpoint/2015/10/main">
   <p1510:revLst>
-    <p1510:client id="{A408838F-B7D8-9C4B-BB2C-90501A19BDA5}" v="72" dt="2025-08-18T20:02:22.467"/>
+    <p1510:client id="{A408838F-B7D8-9C4B-BB2C-90501A19BDA5}" v="132" dt="2025-08-18T21:55:38.057"/>
   </p1510:revLst>
 </p1510:revInfo>
 </file>
@@ -122,7 +122,7 @@
   <pc:docChgLst>
     <pc:chgData name="Sam Khalil" userId="82cd1ec2-6208-465b-9d4d-40ce8f0cbf96" providerId="ADAL" clId="{A408838F-B7D8-9C4B-BB2C-90501A19BDA5}"/>
     <pc:docChg chg="undo custSel addSld delSld modSld addMainMaster delMainMaster modMainMaster">
-      <pc:chgData name="Sam Khalil" userId="82cd1ec2-6208-465b-9d4d-40ce8f0cbf96" providerId="ADAL" clId="{A408838F-B7D8-9C4B-BB2C-90501A19BDA5}" dt="2025-08-18T20:25:30.914" v="418" actId="14429"/>
+      <pc:chgData name="Sam Khalil" userId="82cd1ec2-6208-465b-9d4d-40ce8f0cbf96" providerId="ADAL" clId="{A408838F-B7D8-9C4B-BB2C-90501A19BDA5}" dt="2025-08-18T21:55:38.057" v="702"/>
       <pc:docMkLst>
         <pc:docMk/>
       </pc:docMkLst>
@@ -287,6 +287,21 @@
           <pc:docMk/>
           <pc:sldMk cId="2209653406" sldId="256"/>
         </pc:sldMkLst>
+      </pc:sldChg>
+      <pc:sldChg chg="modSp new del mod">
+        <pc:chgData name="Sam Khalil" userId="82cd1ec2-6208-465b-9d4d-40ce8f0cbf96" providerId="ADAL" clId="{A408838F-B7D8-9C4B-BB2C-90501A19BDA5}" dt="2025-08-18T21:44:45.973" v="528" actId="680"/>
+        <pc:sldMkLst>
+          <pc:docMk/>
+          <pc:sldMk cId="3252099291" sldId="256"/>
+        </pc:sldMkLst>
+        <pc:spChg chg="mod">
+          <ac:chgData name="Sam Khalil" userId="82cd1ec2-6208-465b-9d4d-40ce8f0cbf96" providerId="ADAL" clId="{A408838F-B7D8-9C4B-BB2C-90501A19BDA5}" dt="2025-08-18T21:44:45.152" v="527" actId="20577"/>
+          <ac:spMkLst>
+            <pc:docMk/>
+            <pc:sldMk cId="3252099291" sldId="256"/>
+            <ac:spMk id="10" creationId="{FBCB1FB3-25F7-CD89-D5EF-F9BE498ED61F}"/>
+          </ac:spMkLst>
+        </pc:spChg>
       </pc:sldChg>
       <pc:sldChg chg="add del">
         <pc:chgData name="Sam Khalil" userId="82cd1ec2-6208-465b-9d4d-40ce8f0cbf96" providerId="ADAL" clId="{A408838F-B7D8-9C4B-BB2C-90501A19BDA5}" dt="2025-08-18T18:15:16.799" v="72" actId="2696"/>
@@ -1155,7 +1170,7 @@
         </pc:sldLayoutChg>
       </pc:sldMasterChg>
       <pc:sldMasterChg chg="delSp new mod addSldLayout modSldLayout">
-        <pc:chgData name="Sam Khalil" userId="82cd1ec2-6208-465b-9d4d-40ce8f0cbf96" providerId="ADAL" clId="{A408838F-B7D8-9C4B-BB2C-90501A19BDA5}" dt="2025-08-18T20:25:30.914" v="418" actId="14429"/>
+        <pc:chgData name="Sam Khalil" userId="82cd1ec2-6208-465b-9d4d-40ce8f0cbf96" providerId="ADAL" clId="{A408838F-B7D8-9C4B-BB2C-90501A19BDA5}" dt="2025-08-18T21:55:38.057" v="702"/>
         <pc:sldMasterMkLst>
           <pc:docMk/>
           <pc:sldMasterMk cId="2617004005" sldId="2147483676"/>
@@ -1288,14 +1303,32 @@
             <pc:sldLayoutMk cId="1309391717" sldId="2147483687"/>
           </pc:sldLayoutMkLst>
         </pc:sldLayoutChg>
-        <pc:sldLayoutChg chg="addSp delSp modSp mod">
-          <pc:chgData name="Sam Khalil" userId="82cd1ec2-6208-465b-9d4d-40ce8f0cbf96" providerId="ADAL" clId="{A408838F-B7D8-9C4B-BB2C-90501A19BDA5}" dt="2025-08-18T20:25:30.914" v="418" actId="14429"/>
+        <pc:sldLayoutChg chg="addSp delSp modSp mod modAnim">
+          <pc:chgData name="Sam Khalil" userId="82cd1ec2-6208-465b-9d4d-40ce8f0cbf96" providerId="ADAL" clId="{A408838F-B7D8-9C4B-BB2C-90501A19BDA5}" dt="2025-08-18T21:55:38.057" v="702"/>
           <pc:sldLayoutMkLst>
             <pc:docMk/>
             <pc:sldMasterMk cId="2617004005" sldId="2147483676"/>
             <pc:sldLayoutMk cId="4137649368" sldId="2147483688"/>
           </pc:sldLayoutMkLst>
           <pc:spChg chg="add del">
+            <ac:chgData name="Sam Khalil" userId="82cd1ec2-6208-465b-9d4d-40ce8f0cbf96" providerId="ADAL" clId="{A408838F-B7D8-9C4B-BB2C-90501A19BDA5}" dt="2025-08-18T21:55:01.358" v="674" actId="478"/>
+            <ac:spMkLst>
+              <pc:docMk/>
+              <pc:sldMasterMk cId="2617004005" sldId="2147483676"/>
+              <pc:sldLayoutMk cId="4137649368" sldId="2147483688"/>
+              <ac:spMk id="3" creationId="{2DD069AF-AA03-98E2-7DDF-64849CC11217}"/>
+            </ac:spMkLst>
+          </pc:spChg>
+          <pc:spChg chg="add del mod">
+            <ac:chgData name="Sam Khalil" userId="82cd1ec2-6208-465b-9d4d-40ce8f0cbf96" providerId="ADAL" clId="{A408838F-B7D8-9C4B-BB2C-90501A19BDA5}" dt="2025-08-18T21:39:03.469" v="422"/>
+            <ac:spMkLst>
+              <pc:docMk/>
+              <pc:sldMasterMk cId="2617004005" sldId="2147483676"/>
+              <pc:sldLayoutMk cId="4137649368" sldId="2147483688"/>
+              <ac:spMk id="3" creationId="{5E2EFBFD-FD32-0823-C7A7-FD8D607F5A8B}"/>
+            </ac:spMkLst>
+          </pc:spChg>
+          <pc:spChg chg="add del">
             <ac:chgData name="Sam Khalil" userId="82cd1ec2-6208-465b-9d4d-40ce8f0cbf96" providerId="ADAL" clId="{A408838F-B7D8-9C4B-BB2C-90501A19BDA5}" dt="2025-08-18T19:55:00.485" v="206" actId="11529"/>
             <ac:spMkLst>
               <pc:docMk/>
@@ -1332,7 +1365,7 @@
             </ac:spMkLst>
           </pc:spChg>
           <pc:spChg chg="add mod modVis">
-            <ac:chgData name="Sam Khalil" userId="82cd1ec2-6208-465b-9d4d-40ce8f0cbf96" providerId="ADAL" clId="{A408838F-B7D8-9C4B-BB2C-90501A19BDA5}" dt="2025-08-18T20:02:22.467" v="416" actId="962"/>
+            <ac:chgData name="Sam Khalil" userId="82cd1ec2-6208-465b-9d4d-40ce8f0cbf96" providerId="ADAL" clId="{A408838F-B7D8-9C4B-BB2C-90501A19BDA5}" dt="2025-08-18T21:44:31.475" v="511" actId="20577"/>
             <ac:spMkLst>
               <pc:docMk/>
               <pc:sldMasterMk cId="2617004005" sldId="2147483676"/>
@@ -1386,7 +1419,7 @@
             </ac:spMkLst>
           </pc:spChg>
           <pc:spChg chg="mod">
-            <ac:chgData name="Sam Khalil" userId="82cd1ec2-6208-465b-9d4d-40ce8f0cbf96" providerId="ADAL" clId="{A408838F-B7D8-9C4B-BB2C-90501A19BDA5}" dt="2025-08-18T19:54:15.351" v="204"/>
+            <ac:chgData name="Sam Khalil" userId="82cd1ec2-6208-465b-9d4d-40ce8f0cbf96" providerId="ADAL" clId="{A408838F-B7D8-9C4B-BB2C-90501A19BDA5}" dt="2025-08-18T21:55:38.057" v="702"/>
             <ac:spMkLst>
               <pc:docMk/>
               <pc:sldMasterMk cId="2617004005" sldId="2147483676"/>
@@ -1395,7 +1428,16 @@
             </ac:spMkLst>
           </pc:spChg>
           <pc:spChg chg="mod">
-            <ac:chgData name="Sam Khalil" userId="82cd1ec2-6208-465b-9d4d-40ce8f0cbf96" providerId="ADAL" clId="{A408838F-B7D8-9C4B-BB2C-90501A19BDA5}" dt="2025-08-18T20:00:46.243" v="410" actId="207"/>
+            <ac:chgData name="Sam Khalil" userId="82cd1ec2-6208-465b-9d4d-40ce8f0cbf96" providerId="ADAL" clId="{A408838F-B7D8-9C4B-BB2C-90501A19BDA5}" dt="2025-08-18T21:55:33.707" v="700" actId="20577"/>
+            <ac:spMkLst>
+              <pc:docMk/>
+              <pc:sldMasterMk cId="2617004005" sldId="2147483676"/>
+              <pc:sldLayoutMk cId="4137649368" sldId="2147483688"/>
+              <ac:spMk id="18" creationId="{CE374272-FB03-5745-957C-1E272EF9C6E6}"/>
+            </ac:spMkLst>
+          </pc:spChg>
+          <pc:spChg chg="mod">
+            <ac:chgData name="Sam Khalil" userId="82cd1ec2-6208-465b-9d4d-40ce8f0cbf96" providerId="ADAL" clId="{A408838F-B7D8-9C4B-BB2C-90501A19BDA5}" dt="2025-08-18T21:42:59.229" v="477" actId="20577"/>
             <ac:spMkLst>
               <pc:docMk/>
               <pc:sldMasterMk cId="2617004005" sldId="2147483676"/>
@@ -1404,7 +1446,7 @@
             </ac:spMkLst>
           </pc:spChg>
           <pc:spChg chg="mod">
-            <ac:chgData name="Sam Khalil" userId="82cd1ec2-6208-465b-9d4d-40ce8f0cbf96" providerId="ADAL" clId="{A408838F-B7D8-9C4B-BB2C-90501A19BDA5}" dt="2025-08-18T19:53:33.948" v="189" actId="20577"/>
+            <ac:chgData name="Sam Khalil" userId="82cd1ec2-6208-465b-9d4d-40ce8f0cbf96" providerId="ADAL" clId="{A408838F-B7D8-9C4B-BB2C-90501A19BDA5}" dt="2025-08-18T21:42:40.161" v="442" actId="20577"/>
             <ac:spMkLst>
               <pc:docMk/>
               <pc:sldMasterMk cId="2617004005" sldId="2147483676"/>
@@ -1413,7 +1455,7 @@
             </ac:spMkLst>
           </pc:spChg>
           <pc:picChg chg="mod modVis">
-            <ac:chgData name="Sam Khalil" userId="82cd1ec2-6208-465b-9d4d-40ce8f0cbf96" providerId="ADAL" clId="{A408838F-B7D8-9C4B-BB2C-90501A19BDA5}" dt="2025-08-18T20:25:30.914" v="418" actId="14429"/>
+            <ac:chgData name="Sam Khalil" userId="82cd1ec2-6208-465b-9d4d-40ce8f0cbf96" providerId="ADAL" clId="{A408838F-B7D8-9C4B-BB2C-90501A19BDA5}" dt="2025-08-18T21:44:29.120" v="510" actId="1076"/>
             <ac:picMkLst>
               <pc:docMk/>
               <pc:sldMasterMk cId="2617004005" sldId="2147483676"/>
@@ -1695,9 +1737,9 @@
           <a:lstStyle>
             <a:lvl1pPr marL="0" indent="0">
               <a:buNone/>
-              <a:defRPr sz="1400">
+              <a:defRPr sz="1400" baseline="0">
                 <a:solidFill>
-                  <a:schemeClr val="bg1"/>
+                  <a:srgbClr val="FFFFFF"/>
                 </a:solidFill>
                 <a:latin typeface="Helvetica" pitchFamily="2" charset="0"/>
               </a:defRPr>
@@ -1706,7 +1748,22 @@
           <a:p>
             <a:r>
               <a:rPr lang="en-US" dirty="0"/>
-              <a:t>HTML content to be inserted here. Can be Text, images, infographics or other.</a:t>
+              <a:t>HTML content to be inserted here, keep very minimal, this will be on a dark background so light colors and transparent background. Favor Large icons and large text.</a:t>
+            </a:r>
+            <a:br>
+              <a:rPr lang="en-US" dirty="0"/>
+            </a:br>
+            <a:r>
+              <a:rPr lang="en-US" dirty="0"/>
+              <a:t>Should be 430x920 </a:t>
+            </a:r>
+            <a:r>
+              <a:rPr lang="en-US" dirty="0" err="1"/>
+              <a:t>px</a:t>
+            </a:r>
+            <a:r>
+              <a:rPr lang="en-US" dirty="0"/>
+              <a:t>.</a:t>
             </a:r>
           </a:p>
         </p:txBody>
@@ -1756,7 +1813,7 @@
               <a:tabLst/>
               <a:defRPr lang="en-US" sz="1400" noProof="0" dirty="0" smtClean="0">
                 <a:solidFill>
-                  <a:schemeClr val="bg1"/>
+                  <a:srgbClr val="FFFFFF"/>
                 </a:solidFill>
                 <a:latin typeface="Helvetica" pitchFamily="2" charset="0"/>
               </a:defRPr>
@@ -1765,7 +1822,21 @@
           <a:p>
             <a:r>
               <a:rPr lang="en-US" dirty="0"/>
-              <a:t>HTML content to be inserted here. Can be Text, images, infographics or other.</a:t>
+              <a:t>HTML content to be inserted here, keep very minimal, this will be on a dark background so light colors and transparent background. Favor Large icons and large text.</a:t>
+            </a:r>
+          </a:p>
+          <a:p>
+            <a:r>
+              <a:rPr lang="en-US" dirty="0"/>
+              <a:t>Should be 430x920 </a:t>
+            </a:r>
+            <a:r>
+              <a:rPr lang="en-US" dirty="0" err="1"/>
+              <a:t>px</a:t>
+            </a:r>
+            <a:r>
+              <a:rPr lang="en-US" dirty="0"/>
+              <a:t>.</a:t>
             </a:r>
           </a:p>
         </p:txBody>
@@ -1802,7 +1873,7 @@
               <a:buNone/>
               <a:defRPr lang="en-US" sz="1000" b="0" baseline="0" smtClean="0">
                 <a:solidFill>
-                  <a:schemeClr val="bg1"/>
+                  <a:srgbClr val="FFFFFF"/>
                 </a:solidFill>
                 <a:effectLst/>
                 <a:latin typeface="Helvetica" pitchFamily="2" charset="0"/>
@@ -1833,7 +1904,7 @@
             <a:pPr lvl="0"/>
             <a:r>
               <a:rPr lang="en-US" dirty="0"/>
-              <a:t>Subtitle</a:t>
+              <a:t>Subtitle – Max 10-15 words</a:t>
             </a:r>
           </a:p>
           <a:p>
@@ -1881,7 +1952,7 @@
               <a:buNone/>
               <a:defRPr sz="1800" b="1">
                 <a:solidFill>
-                  <a:schemeClr val="bg1"/>
+                  <a:srgbClr val="FFFFFF"/>
                 </a:solidFill>
                 <a:latin typeface="Helvetica" pitchFamily="2" charset="0"/>
                 <a:cs typeface="Calibri" panose="020F0502020204030204" pitchFamily="34" charset="0"/>
@@ -1920,7 +1991,7 @@
             <a:pPr lvl="0"/>
             <a:r>
               <a:rPr lang="en-US" dirty="0"/>
-              <a:t>Title</a:t>
+              <a:t>Title 3-4 words only</a:t>
             </a:r>
           </a:p>
         </p:txBody>
@@ -1953,8 +2024,13 @@
         <p:txBody>
           <a:bodyPr/>
           <a:lstStyle>
-            <a:lvl1pPr marL="0" indent="0">
-              <a:buNone/>
+            <a:lvl1pPr marL="61913" indent="-61913" algn="l">
+              <a:spcBef>
+                <a:spcPts val="0"/>
+              </a:spcBef>
+              <a:buFont typeface="Arial" panose="020B0604020202020204" pitchFamily="34" charset="0"/>
+              <a:buChar char="•"/>
+              <a:tabLst/>
               <a:defRPr sz="460" b="1">
                 <a:solidFill>
                   <a:srgbClr val="002060"/>
@@ -2684,6 +2760,26 @@
 </file>
 
 <file path=customXml/item1.xml><?xml version="1.0" encoding="utf-8"?>
+<p:properties xmlns:p="http://schemas.microsoft.com/office/2006/metadata/properties" xmlns:xsi="http://www.w3.org/2001/XMLSchema-instance" xmlns:pc="http://schemas.microsoft.com/office/infopath/2007/PartnerControls">
+  <documentManagement>
+    <TaxCatchAll xmlns="2bdccfd7-ed75-47c4-ae3e-45ba8291135b" xsi:nil="true"/>
+    <lcf76f155ced4ddcb4097134ff3c332f xmlns="bdfda862-7558-4f4e-99f8-648970d7935e">
+      <Terms xmlns="http://schemas.microsoft.com/office/infopath/2007/PartnerControls"/>
+    </lcf76f155ced4ddcb4097134ff3c332f>
+  </documentManagement>
+</p:properties>
+</file>
+
+<file path=customXml/item2.xml><?xml version="1.0" encoding="utf-8"?>
+<?mso-contentType ?>
+<FormTemplates xmlns="http://schemas.microsoft.com/sharepoint/v3/contenttype/forms">
+  <Display>DocumentLibraryForm</Display>
+  <Edit>DocumentLibraryForm</Edit>
+  <New>DocumentLibraryForm</New>
+</FormTemplates>
+</file>
+
+<file path=customXml/item3.xml><?xml version="1.0" encoding="utf-8"?>
 <ct:contentTypeSchema xmlns:ct="http://schemas.microsoft.com/office/2006/metadata/contentType" xmlns:ma="http://schemas.microsoft.com/office/2006/metadata/properties/metaAttributes" ct:_="" ma:_="" ma:contentTypeName="Document" ma:contentTypeID="0x0101009D55CCFAD34A484FAC43376D580F7497" ma:contentTypeVersion="13" ma:contentTypeDescription="Create a new document." ma:contentTypeScope="" ma:versionID="20fcfebd8cb07aba400aa359cb6a137d">
   <xsd:schema xmlns:xsd="http://www.w3.org/2001/XMLSchema" xmlns:xs="http://www.w3.org/2001/XMLSchema" xmlns:p="http://schemas.microsoft.com/office/2006/metadata/properties" xmlns:ns2="bdfda862-7558-4f4e-99f8-648970d7935e" xmlns:ns3="2bdccfd7-ed75-47c4-ae3e-45ba8291135b" targetNamespace="http://schemas.microsoft.com/office/2006/metadata/properties" ma:root="true" ma:fieldsID="e7232410060904e04ccc6d86ba125b69" ns2:_="" ns3:_="">
     <xsd:import namespace="bdfda862-7558-4f4e-99f8-648970d7935e"/>
@@ -2890,27 +2986,32 @@
 </ct:contentTypeSchema>
 </file>
 
-<file path=customXml/item2.xml><?xml version="1.0" encoding="utf-8"?>
-<?mso-contentType ?>
-<FormTemplates xmlns="http://schemas.microsoft.com/sharepoint/v3/contenttype/forms">
-  <Display>DocumentLibraryForm</Display>
-  <Edit>DocumentLibraryForm</Edit>
-  <New>DocumentLibraryForm</New>
-</FormTemplates>
+<file path=customXml/itemProps1.xml><?xml version="1.0" encoding="utf-8"?>
+<ds:datastoreItem xmlns:ds="http://schemas.openxmlformats.org/officeDocument/2006/customXml" ds:itemID="{07B25C73-F9B8-4163-9F48-0CB0D416CA9F}">
+  <ds:schemaRefs>
+    <ds:schemaRef ds:uri="2bdccfd7-ed75-47c4-ae3e-45ba8291135b"/>
+    <ds:schemaRef ds:uri="bdfda862-7558-4f4e-99f8-648970d7935e"/>
+    <ds:schemaRef ds:uri="http://www.w3.org/XML/1998/namespace"/>
+    <ds:schemaRef ds:uri="http://purl.org/dc/dcmitype/"/>
+    <ds:schemaRef ds:uri="http://purl.org/dc/elements/1.1/"/>
+    <ds:schemaRef ds:uri="http://purl.org/dc/terms/"/>
+    <ds:schemaRef ds:uri="http://schemas.microsoft.com/office/2006/documentManagement/types"/>
+    <ds:schemaRef ds:uri="http://schemas.microsoft.com/office/infopath/2007/PartnerControls"/>
+    <ds:schemaRef ds:uri="http://schemas.openxmlformats.org/package/2006/metadata/core-properties"/>
+    <ds:schemaRef ds:uri="http://schemas.microsoft.com/office/2006/metadata/properties"/>
+  </ds:schemaRefs>
+</ds:datastoreItem>
 </file>
 
-<file path=customXml/item3.xml><?xml version="1.0" encoding="utf-8"?>
-<p:properties xmlns:p="http://schemas.microsoft.com/office/2006/metadata/properties" xmlns:xsi="http://www.w3.org/2001/XMLSchema-instance" xmlns:pc="http://schemas.microsoft.com/office/infopath/2007/PartnerControls">
-  <documentManagement>
-    <TaxCatchAll xmlns="2bdccfd7-ed75-47c4-ae3e-45ba8291135b" xsi:nil="true"/>
-    <lcf76f155ced4ddcb4097134ff3c332f xmlns="bdfda862-7558-4f4e-99f8-648970d7935e">
-      <Terms xmlns="http://schemas.microsoft.com/office/infopath/2007/PartnerControls"/>
-    </lcf76f155ced4ddcb4097134ff3c332f>
-  </documentManagement>
-</p:properties>
+<file path=customXml/itemProps2.xml><?xml version="1.0" encoding="utf-8"?>
+<ds:datastoreItem xmlns:ds="http://schemas.openxmlformats.org/officeDocument/2006/customXml" ds:itemID="{E87EC857-F007-4173-A949-920B0782013E}">
+  <ds:schemaRefs>
+    <ds:schemaRef ds:uri="http://schemas.microsoft.com/sharepoint/v3/contenttype/forms"/>
+  </ds:schemaRefs>
+</ds:datastoreItem>
 </file>
 
-<file path=customXml/itemProps1.xml><?xml version="1.0" encoding="utf-8"?>
+<file path=customXml/itemProps3.xml><?xml version="1.0" encoding="utf-8"?>
 <ds:datastoreItem xmlns:ds="http://schemas.openxmlformats.org/officeDocument/2006/customXml" ds:itemID="{97B64CF5-E1EF-40C6-BCE9-DABD3E7E5869}">
   <ds:schemaRefs>
     <ds:schemaRef ds:uri="http://schemas.microsoft.com/office/2006/metadata/contentType"/>
@@ -2927,29 +3028,4 @@
     <ds:schemaRef ds:uri="http://schemas.microsoft.com/internal/obd"/>
   </ds:schemaRefs>
 </ds:datastoreItem>
-</file>
-
-<file path=customXml/itemProps2.xml><?xml version="1.0" encoding="utf-8"?>
-<ds:datastoreItem xmlns:ds="http://schemas.openxmlformats.org/officeDocument/2006/customXml" ds:itemID="{E87EC857-F007-4173-A949-920B0782013E}">
-  <ds:schemaRefs>
-    <ds:schemaRef ds:uri="http://schemas.microsoft.com/sharepoint/v3/contenttype/forms"/>
-  </ds:schemaRefs>
-</ds:datastoreItem>
-</file>
-
-<file path=customXml/itemProps3.xml><?xml version="1.0" encoding="utf-8"?>
-<ds:datastoreItem xmlns:ds="http://schemas.openxmlformats.org/officeDocument/2006/customXml" ds:itemID="{07B25C73-F9B8-4163-9F48-0CB0D416CA9F}">
-  <ds:schemaRefs>
-    <ds:schemaRef ds:uri="http://schemas.microsoft.com/office/2006/metadata/properties"/>
-    <ds:schemaRef ds:uri="bdfda862-7558-4f4e-99f8-648970d7935e"/>
-    <ds:schemaRef ds:uri="http://purl.org/dc/terms/"/>
-    <ds:schemaRef ds:uri="http://purl.org/dc/dcmitype/"/>
-    <ds:schemaRef ds:uri="http://schemas.microsoft.com/office/infopath/2007/PartnerControls"/>
-    <ds:schemaRef ds:uri="http://schemas.microsoft.com/office/2006/documentManagement/types"/>
-    <ds:schemaRef ds:uri="http://schemas.openxmlformats.org/package/2006/metadata/core-properties"/>
-    <ds:schemaRef ds:uri="2bdccfd7-ed75-47c4-ae3e-45ba8291135b"/>
-    <ds:schemaRef ds:uri="http://www.w3.org/XML/1998/namespace"/>
-    <ds:schemaRef ds:uri="http://purl.org/dc/elements/1.1/"/>
-  </ds:schemaRefs>
-</ds:datastoreItem>
 </file>
</xml_diff>